<commit_message>
Update documentation with Activity 4 results (range ratios, Pearson r=0.999)
</commit_message>
<xml_diff>
--- a/documentation/docx/DACS_Manager_Briefing.pptx
+++ b/documentation/docx/DACS_Manager_Briefing.pptx
@@ -12833,7 +12833,7 @@
                 </a:solidFill>
                 <a:latin typeface="Calibri"/>
               </a:rPr>
-              <a:t>⏳ TODO</a:t>
+              <a:t>✅ DONE</a:t>
             </a:r>
           </a:p>
         </p:txBody>
@@ -15372,7 +15372,7 @@
                 </a:solidFill>
                 <a:latin typeface="Calibri"/>
               </a:rPr>
-              <a:t>Activity 3 Complete — 3-Domain Sensitivity Map Confirmed</a:t>
+              <a:t>Activity 4 Complete — Mechanism Confirmed (Pearson r = 0.999)</a:t>
             </a:r>
           </a:p>
         </p:txBody>
@@ -15670,7 +15670,7 @@
                 </a:solidFill>
                 <a:latin typeface="Calibri"/>
               </a:rPr>
-              <a:t>TODAY ← Apr 14</a:t>
+              <a:t>TODAY ← Apr 18</a:t>
             </a:r>
           </a:p>
         </p:txBody>
@@ -16443,7 +16443,7 @@
                 </a:solidFill>
                 <a:latin typeface="Calibri"/>
               </a:rPr>
-              <a:t>Act. 4: activation-distribution analysis. Validates SQ C2 mechanism + diagnostic metric.</a:t>
+              <a:t>Act. 4: COMPLETE ✓ — Activation range analysis. Cyber C2 gap=0.212 (100% layers), Pearson r=0.999. Mechanism confirmed. Figs 5+6 in paper.</a:t>
             </a:r>
           </a:p>
         </p:txBody>
@@ -17906,7 +17906,7 @@
                 </a:solidFill>
                 <a:latin typeface="Calibri"/>
               </a:rPr>
-              <a:t>35–40% with Act3 complete</a:t>
+              <a:t>45–55% with Act4 complete</a:t>
             </a:r>
           </a:p>
         </p:txBody>
@@ -17990,7 +17990,7 @@
                 </a:solidFill>
                 <a:latin typeface="Calibri"/>
               </a:rPr>
-              <a:t>60–65% with Act3 complete</a:t>
+              <a:t>70–75% with Act4 complete</a:t>
             </a:r>
           </a:p>
         </p:txBody>

</xml_diff>